<commit_message>
docs: record end-to-end COIN and cash payment results for machine sessions
</commit_message>
<xml_diff>
--- a/doc/slide/shogun-payment-notification.pptx
+++ b/doc/slide/shogun-payment-notification.pptx
@@ -1244,7 +1244,7 @@
           <a:lstStyle/>
           <a:p>
             <a:r>
-              <a:t>ปิดท้ายด้วยข้อจำกัดที่ผมรู้ตรงๆ ครับ ยังไม่มีเทสต์จ่ายซ้ำพร้อมกันจริง สิทธิ์ที่ @PreAuthorize ผมยืนยันด้วยมือ ยังไม่มีเทสต์อัตโนมัติ และเทสต์ที่ต่อฐานข้อมูลเป็นแบบเปิดเองยังไม่รันใน CI สิ่งที่ทำต่อคือเพิ่ม Postgres ใน CI ทำหน้าเว็บชำระเงินกับกล่องแจ้งเตือน และเชื่อมการจ่ายด้วยเหรียญกับรอบใช้เครื่อง ซึ่งขึ้นกับ SessionPayableProvider ของโมดูลเครื่องซัก ก่อนนำเสนอให้ตรวจสถานะข้อนี้และหน้าเว็บอีกครั้ง ขอบคุณครับ</a:t>
+              <a:t>ปิดท้ายด้วยข้อจำกัดที่ผมรู้ตรงๆ ครับ ยังไม่มีเทสต์จ่ายซ้ำพร้อมกันจริง สิทธิ์ที่ @PreAuthorize ผมยืนยันด้วยมือ ยังไม่มีเทสต์อัตโนมัติ และเทสต์ที่ต่อฐานข้อมูลเป็นแบบเปิดเองยังไม่รันใน CI สิ่งที่ทำต่อคือเพิ่ม Postgres ใน CI ทำหน้าเว็บชำระเงินกับกล่องแจ้งเตือน และทำให้จองเครื่องผ่านหน้าเว็บหรือ API ได้ เพื่อทดสอบ flow ตั้งแต่จองจนถึงจ่ายเงิน ตอนนี้ผมทดสอบการจ่ายด้วยเหรียญกับรอบใช้เครื่องแล้ว โดยใส่รอบใช้เครื่องลงฐานข้อมูลเอง ก่อนนำเสนอให้ตรวจสถานะหน้าเว็บอีกครั้ง ขอบคุณครับ</a:t>
             </a:r>
           </a:p>
         </p:txBody>
@@ -5378,7 +5378,7 @@
                 <a:ea typeface="Tahoma"/>
                 <a:cs typeface="Tahoma"/>
               </a:rPr>
-              <a:t>14</a:t>
+              <a:t>22</a:t>
             </a:r>
           </a:p>
         </p:txBody>
@@ -10444,7 +10444,7 @@
                 <a:ea typeface="Tahoma"/>
                 <a:cs typeface="Tahoma"/>
               </a:rPr>
-              <a:t>•  เชื่อม COIN กับรอบใช้เครื่อง (ขึ้นกับ SessionPayableProvider)</a:t>
+              <a:t>•  จองเครื่องผ่านหน้าเว็บ / API (ตอนนี้ทดสอบ COIN ด้วยรอบใช้เครื่องที่ใส่ใน DB)</a:t>
             </a:r>
           </a:p>
         </p:txBody>

</xml_diff>

<commit_message>
feat: add payment and notification web pages, return 404 for unknown URLs
</commit_message>
<xml_diff>
--- a/doc/slide/shogun-payment-notification.pptx
+++ b/doc/slide/shogun-payment-notification.pptx
@@ -193,16 +193,16 @@
                 <c:formatCode>General</c:formatCode>
                 <c:ptCount val="4"/>
                 <c:pt idx="0">
-                  <c:v>81</c:v>
+                  <c:v>102</c:v>
                 </c:pt>
                 <c:pt idx="1">
                   <c:v>29</c:v>
                 </c:pt>
                 <c:pt idx="2">
-                  <c:v>38</c:v>
+                  <c:v>69</c:v>
                 </c:pt>
                 <c:pt idx="3">
-                  <c:v>55</c:v>
+                  <c:v>97</c:v>
                 </c:pt>
               </c:numCache>
             </c:numRef>
@@ -1104,7 +1104,7 @@
           <a:lstStyle/>
           <a:p>
             <a:r>
-              <a:t>เรื่องการทดสอบ ตัวเลขทางซ้าย: 81 unit test ของโมดูลผมผ่านทั้งหมด 13 เทสต์ตรวจ constraint กับ PostgreSQL จริง และรอบเต็มของทั้งโปรเจคมี 225 เทสต์ผ่านหมด ข้าม 22 ข้อที่ต้องเปิดฐานข้อมูลเอง กราฟขวาแสดงเทสต์ที่ผ่านในรอบปกติแยกตามโมดูล ของปอนด์อีก 19 ข้อเป็นเทสต์ที่ต้องต่อฐานข้อมูลและรันแยกแล้วผ่าน ตรวจตัวเลขทั้งหมดกับ doc/test-report ก่อนนำเสนออีกครั้ง</a:t>
+              <a:t>เรื่องการทดสอบ ตัวเลขทางซ้าย: 102 unit test ของโมดูลผมผ่านทั้งหมด รวมเทสต์หน้าเว็บ 20 ข้อ 13 เทสต์ตรวจ constraint กับ PostgreSQL จริง และรอบเต็มของทั้งโปรเจคมี 332 เทสต์ผ่านหมด ข้าม 35 ข้อที่ต้องเปิดฐานข้อมูลเอง ซึ่งเมื่อเปิดแล้วรันครบ 342 ข้อ ผ่านทั้งหมด กราฟขวาแสดงเทสต์ที่ผ่านในรอบปกติแยกตามโมดูล ของปอนด์มีเทสต์ที่ต้องต่อฐานข้อมูลอีก 22 ข้อ ซึ่งรันแล้วผ่านเมื่อเปิดสวิตช์ ตรวจตัวเลขทั้งหมดกับ doc/test-report ก่อนนำเสนออีกครั้ง</a:t>
             </a:r>
           </a:p>
         </p:txBody>
@@ -1244,7 +1244,7 @@
           <a:lstStyle/>
           <a:p>
             <a:r>
-              <a:t>ปิดท้ายด้วยข้อจำกัดที่ผมรู้ตรงๆ ครับ ยังไม่มีเทสต์จ่ายซ้ำพร้อมกันจริง สิทธิ์ที่ @PreAuthorize ผมยืนยันด้วยมือ ยังไม่มีเทสต์อัตโนมัติ และเทสต์ที่ต่อฐานข้อมูลเป็นแบบเปิดเองยังไม่รันใน CI สิ่งที่ทำต่อคือเพิ่ม Postgres ใน CI ทำหน้าเว็บชำระเงินกับกล่องแจ้งเตือน และทำให้จองเครื่องผ่านหน้าเว็บหรือ API ได้ เพื่อทดสอบ flow ตั้งแต่จองจนถึงจ่ายเงิน ตอนนี้ผมทดสอบการจ่ายด้วยเหรียญกับรอบใช้เครื่องแล้ว โดยใส่รอบใช้เครื่องลงฐานข้อมูลเอง ก่อนนำเสนอให้ตรวจสถานะหน้าเว็บอีกครั้ง ขอบคุณครับ</a:t>
+              <a:t>ปิดท้ายด้วยข้อจำกัดที่ผมรู้ตรงๆ ครับ ยังไม่มีเทสต์จ่ายซ้ำพร้อมกันจริง สิทธิ์ที่ @PreAuthorize ผมยืนยันด้วยมือ ยังไม่มีเทสต์อัตโนมัติ และเทสต์ที่ต่อฐานข้อมูลเป็นแบบเปิดเองยังไม่รันใน CI หน้าเว็บชำระเงินกับกล่องแจ้งเตือนทำเสร็จแล้ว แต่ยังไม่มีเทสต์ที่ render template อัตโนมัติ ผมเจอบั๊ก dropdown ว่างตอนเปิดหน้าจริง ซึ่งเทสต์ระดับ controller จับไม่ได้ สิ่งที่ทำต่อคือเพิ่ม Postgres ใน CI เพิ่มเทสต์ render หน้าเว็บ และทำหน้าเว็บจองเครื่องต่อจาก API จองเครื่องที่ปอนด์ทำไว้แล้ว เพื่อทดสอบ flow ตั้งแต่จองจนถึงจ่ายเงินผ่านหน้าเว็บ ขอบคุณครับ</a:t>
             </a:r>
           </a:p>
         </p:txBody>
@@ -4751,7 +4751,7 @@
                 <a:ea typeface="Tahoma"/>
                 <a:cs typeface="Tahoma"/>
               </a:rPr>
-              <a:t>•  REST API 4 endpoint</a:t>
+              <a:t>•  REST API 4 endpoint + หน้าเว็บ</a:t>
             </a:r>
           </a:p>
         </p:txBody>
@@ -4892,7 +4892,7 @@
                 <a:ea typeface="Tahoma"/>
                 <a:cs typeface="Tahoma"/>
               </a:rPr>
-              <a:t>•  REST API ดู / กรองยังไม่อ่าน</a:t>
+              <a:t>•  REST API + หน้าเว็บแจ้งเตือน</a:t>
             </a:r>
           </a:p>
         </p:txBody>
@@ -5120,7 +5120,7 @@
                 <a:ea typeface="Tahoma"/>
                 <a:cs typeface="Tahoma"/>
               </a:rPr>
-              <a:t>81</a:t>
+              <a:t>102</a:t>
             </a:r>
           </a:p>
         </p:txBody>
@@ -8819,7 +8819,7 @@
                 <a:ea typeface="Tahoma"/>
                 <a:cs typeface="Tahoma"/>
               </a:rPr>
-              <a:t>81</a:t>
+              <a:t>102</a:t>
             </a:r>
           </a:p>
         </p:txBody>
@@ -9077,7 +9077,7 @@
                 <a:ea typeface="Tahoma"/>
                 <a:cs typeface="Tahoma"/>
               </a:rPr>
-              <a:t>225</a:t>
+              <a:t>332</a:t>
             </a:r>
           </a:p>
         </p:txBody>
@@ -9119,7 +9119,7 @@
                 <a:cs typeface="Tahoma"/>
               </a:rPr>
               <a:t>เทสต์ทั้งโปรเจค ผ่านหมด
-(ข้าม 22 ที่ต้องเปิด DB)</a:t>
+(ข้าม 35 ที่ต้องเปิด DB)</a:t>
             </a:r>
           </a:p>
         </p:txBody>
@@ -9178,7 +9178,7 @@
                 <a:ea typeface="Tahoma"/>
                 <a:cs typeface="Tahoma"/>
               </a:rPr>
-              <a:t>ปอนด์: อีก 19 ข้อเป็นเทสต์ที่ต้องต่อฐานข้อมูล รันแยกแล้วผ่าน</a:t>
+              <a:t>ปอนด์: อีก 22 ข้อเป็นเทสต์ที่ต้องต่อฐานข้อมูล (ข้ามในรอบปกติ) รันแล้วผ่าน</a:t>
             </a:r>
           </a:p>
         </p:txBody>
@@ -10291,6 +10291,24 @@
           <a:p>
             <a:pPr algn="l">
               <a:spcAft>
+                <a:spcPts val="800"/>
+              </a:spcAft>
+            </a:pPr>
+            <a:r>
+              <a:rPr sz="1500" b="0" i="0" lang="th-TH">
+                <a:solidFill>
+                  <a:srgbClr val="FFFFFF"/>
+                </a:solidFill>
+                <a:latin typeface="Tahoma"/>
+                <a:ea typeface="Tahoma"/>
+                <a:cs typeface="Tahoma"/>
+              </a:rPr>
+              <a:t>•  เทสต์ DB เป็นแบบ opt-in ยังไม่รันใน CI</a:t>
+            </a:r>
+          </a:p>
+          <a:p>
+            <a:pPr algn="l">
+              <a:spcAft>
                 <a:spcPts val="0"/>
               </a:spcAft>
             </a:pPr>
@@ -10303,7 +10321,7 @@
                 <a:ea typeface="Tahoma"/>
                 <a:cs typeface="Tahoma"/>
               </a:rPr>
-              <a:t>•  เทสต์ DB เป็นแบบ opt-in ยังไม่รันใน CI</a:t>
+              <a:t>•  หน้าเว็บยังไม่มีเทสต์ที่ render template (ตรวจด้วยการเปิดหน้าจริง)</a:t>
             </a:r>
           </a:p>
         </p:txBody>
@@ -10426,7 +10444,7 @@
                 <a:ea typeface="Tahoma"/>
                 <a:cs typeface="Tahoma"/>
               </a:rPr>
-              <a:t>•  หน้าเว็บชำระเงิน / กล่องแจ้งเตือน</a:t>
+              <a:t>•  เทสต์ render หน้าเว็บอัตโนมัติ</a:t>
             </a:r>
           </a:p>
           <a:p>
@@ -10444,7 +10462,7 @@
                 <a:ea typeface="Tahoma"/>
                 <a:cs typeface="Tahoma"/>
               </a:rPr>
-              <a:t>•  จองเครื่องผ่านหน้าเว็บ / API (ตอนนี้ทดสอบ COIN ด้วยรอบใช้เครื่องที่ใส่ใน DB)</a:t>
+              <a:t>•  หน้าเว็บจองเครื่อง ต่อจาก API จองเครื่อง (API มีแล้ว ทดสอบจองจนจ่ายเงินได้)</a:t>
             </a:r>
           </a:p>
         </p:txBody>

</xml_diff>

<commit_message>
test: add security and template-render tests for payment and notification endpoints
</commit_message>
<xml_diff>
--- a/doc/slide/shogun-payment-notification.pptx
+++ b/doc/slide/shogun-payment-notification.pptx
@@ -202,7 +202,7 @@
                   <c:v>69</c:v>
                 </c:pt>
                 <c:pt idx="3">
-                  <c:v>97</c:v>
+                  <c:v>110</c:v>
                 </c:pt>
               </c:numCache>
             </c:numRef>
@@ -1104,7 +1104,7 @@
           <a:lstStyle/>
           <a:p>
             <a:r>
-              <a:t>เรื่องการทดสอบ ตัวเลขทางซ้าย: 102 unit test ของโมดูลผมผ่านทั้งหมด รวมเทสต์หน้าเว็บ 20 ข้อ 13 เทสต์ตรวจ constraint กับ PostgreSQL จริง และรอบเต็มของทั้งโปรเจคมี 332 เทสต์ผ่านหมด ข้าม 35 ข้อที่ต้องเปิดฐานข้อมูลเอง ซึ่งเมื่อเปิดแล้วรันครบ 342 ข้อ ผ่านทั้งหมด กราฟขวาแสดงเทสต์ที่ผ่านในรอบปกติแยกตามโมดูล ของปอนด์มีเทสต์ที่ต้องต่อฐานข้อมูลอีก 22 ข้อ ซึ่งรันแล้วผ่านเมื่อเปิดสวิตช์ ตรวจตัวเลขทั้งหมดกับ doc/test-report ก่อนนำเสนออีกครั้ง</a:t>
+              <a:t>เรื่องการทดสอบ ตัวเลขทางซ้าย: 102 unit test ของโมดูลผมผ่านทั้งหมด รวมเทสต์หน้าเว็บ 20 ข้อ 13 เทสต์ตรวจ constraint กับ PostgreSQL จริง และรอบเต็มของทั้งโปรเจคมี 346 เทสต์ผ่านหมด ข้าม 36 ข้อที่ต้องเปิดฐานข้อมูลเอง ซึ่งเมื่อเปิดแล้วรันครบ 356 ข้อ ผ่านทั้งหมด กราฟขวาแสดงเทสต์ที่ผ่านในรอบปกติแยกตามโมดูล ของปอนด์มีเทสต์ที่ต้องต่อฐานข้อมูลอีก 23 ข้อ ซึ่งรันแล้วผ่านเมื่อเปิดสวิตช์ ตรวจตัวเลขทั้งหมดกับ doc/test-report ก่อนนำเสนออีกครั้ง</a:t>
             </a:r>
           </a:p>
         </p:txBody>
@@ -1244,7 +1244,7 @@
           <a:lstStyle/>
           <a:p>
             <a:r>
-              <a:t>ปิดท้ายด้วยข้อจำกัดที่ผมรู้ตรงๆ ครับ ยังไม่มีเทสต์จ่ายซ้ำพร้อมกันจริง สิทธิ์ที่ @PreAuthorize ผมยืนยันด้วยมือ ยังไม่มีเทสต์อัตโนมัติ และเทสต์ที่ต่อฐานข้อมูลเป็นแบบเปิดเองยังไม่รันใน CI หน้าเว็บชำระเงินกับกล่องแจ้งเตือนทำเสร็จแล้ว แต่ยังไม่มีเทสต์ที่ render template อัตโนมัติ ผมเจอบั๊ก dropdown ว่างตอนเปิดหน้าจริง ซึ่งเทสต์ระดับ controller จับไม่ได้ สิ่งที่ทำต่อคือเพิ่ม Postgres ใน CI เพิ่มเทสต์ render หน้าเว็บ และทำหน้าเว็บจองเครื่องต่อจาก API จองเครื่องที่ปอนด์ทำไว้แล้ว เพื่อทดสอบ flow ตั้งแต่จองจนถึงจ่ายเงินผ่านหน้าเว็บ ขอบคุณครับ</a:t>
+              <a:t>ปิดท้ายด้วยข้อจำกัดที่ผมรู้ตรงๆ ครับ ยังไม่มีเทสต์จ่ายซ้ำพร้อมกันจริง ส่วนสิทธิ์ @PreAuthorize ตอนนี้มีเทสต์อัตโนมัติแล้ว 13 ข้อ ที่เปิด Spring Security และ render หน้าเว็บจริง เทสต์ที่ต่อฐานข้อมูลเป็นแบบเปิดเองยังไม่รันใน CI หน้าเว็บชำระเงินกับกล่องแจ้งเตือนทำเสร็จแล้ว ผมเจอบั๊ก dropdown ว่างตอนเปิดหน้าจริง จึงเพิ่มเทสต์ render กันไว้ แต่ฟอร์มยังต้องพิมพ์เลขที่รายการเอง สิ่งที่ทำต่อคือเพิ่ม Postgres ใน CI และเพิ่มปุ่มชำระเงินจากหน้าประวัติรอบใช้งานของปอนด์ เพื่อให้ flow ตั้งแต่จองจนถึงจ่ายเงินครบในหน้าเว็บ ขอบคุณครับ</a:t>
             </a:r>
           </a:p>
         </p:txBody>
@@ -9077,7 +9077,7 @@
                 <a:ea typeface="Tahoma"/>
                 <a:cs typeface="Tahoma"/>
               </a:rPr>
-              <a:t>332</a:t>
+              <a:t>346</a:t>
             </a:r>
           </a:p>
         </p:txBody>
@@ -9119,7 +9119,7 @@
                 <a:cs typeface="Tahoma"/>
               </a:rPr>
               <a:t>เทสต์ทั้งโปรเจค ผ่านหมด
-(ข้าม 35 ที่ต้องเปิด DB)</a:t>
+(ข้าม 36 ที่ต้องเปิด DB)</a:t>
             </a:r>
           </a:p>
         </p:txBody>
@@ -9178,7 +9178,7 @@
                 <a:ea typeface="Tahoma"/>
                 <a:cs typeface="Tahoma"/>
               </a:rPr>
-              <a:t>ปอนด์: อีก 22 ข้อเป็นเทสต์ที่ต้องต่อฐานข้อมูล (ข้ามในรอบปกติ) รันแล้วผ่าน</a:t>
+              <a:t>ปอนด์: อีก 23 ข้อเป็นเทสต์ที่ต้องต่อฐานข้อมูล (ข้ามในรอบปกติ) รันแล้วผ่าน</a:t>
             </a:r>
           </a:p>
         </p:txBody>
@@ -10285,7 +10285,7 @@
                 <a:ea typeface="Tahoma"/>
                 <a:cs typeface="Tahoma"/>
               </a:rPr>
-              <a:t>•  @PreAuthorize ยืนยันแบบ manual ยังไม่มีเทสต์อัตโนมัติ</a:t>
+              <a:t>•  เทสต์สิทธิ์ mock service (ไม่ต่อ DB จริง)</a:t>
             </a:r>
           </a:p>
           <a:p>
@@ -10321,7 +10321,7 @@
                 <a:ea typeface="Tahoma"/>
                 <a:cs typeface="Tahoma"/>
               </a:rPr>
-              <a:t>•  หน้าเว็บยังไม่มีเทสต์ที่ render template (ตรวจด้วยการเปิดหน้าจริง)</a:t>
+              <a:t>•  ฟอร์มชำระเงินต้องพิมพ์เลขที่รายการเอง</a:t>
             </a:r>
           </a:p>
         </p:txBody>
@@ -10444,7 +10444,7 @@
                 <a:ea typeface="Tahoma"/>
                 <a:cs typeface="Tahoma"/>
               </a:rPr>
-              <a:t>•  เทสต์ render หน้าเว็บอัตโนมัติ</a:t>
+              <a:t>•  ปุ่มชำระเงินจากหน้าประวัติรอบใช้งาน / ออเดอร์</a:t>
             </a:r>
           </a:p>
           <a:p>

</xml_diff>

<commit_message>
docs: update test totals to 369 (379 with DB tests) and add Payable status limitation
</commit_message>
<xml_diff>
--- a/doc/slide/shogun-payment-notification.pptx
+++ b/doc/slide/shogun-payment-notification.pptx
@@ -193,16 +193,16 @@
                 <c:formatCode>General</c:formatCode>
                 <c:ptCount val="4"/>
                 <c:pt idx="0">
-                  <c:v>102</c:v>
+                  <c:v>115</c:v>
                 </c:pt>
                 <c:pt idx="1">
                   <c:v>29</c:v>
                 </c:pt>
                 <c:pt idx="2">
-                  <c:v>69</c:v>
+                  <c:v>78</c:v>
                 </c:pt>
                 <c:pt idx="3">
-                  <c:v>110</c:v>
+                  <c:v>111</c:v>
                 </c:pt>
               </c:numCache>
             </c:numRef>
@@ -1104,7 +1104,7 @@
           <a:lstStyle/>
           <a:p>
             <a:r>
-              <a:t>เรื่องการทดสอบ ตัวเลขทางซ้าย: 102 unit test ของโมดูลผมผ่านทั้งหมด รวมเทสต์หน้าเว็บ 20 ข้อ 13 เทสต์ตรวจ constraint กับ PostgreSQL จริง และรอบเต็มของทั้งโปรเจคมี 346 เทสต์ผ่านหมด ข้าม 36 ข้อที่ต้องเปิดฐานข้อมูลเอง ซึ่งเมื่อเปิดแล้วรันครบ 356 ข้อ ผ่านทั้งหมด กราฟขวาแสดงเทสต์ที่ผ่านในรอบปกติแยกตามโมดูล ของปอนด์มีเทสต์ที่ต้องต่อฐานข้อมูลอีก 23 ข้อ ซึ่งรันแล้วผ่านเมื่อเปิดสวิตช์ ตรวจตัวเลขทั้งหมดกับ doc/test-report ก่อนนำเสนออีกครั้ง</a:t>
+              <a:t>เรื่องการทดสอบ ตัวเลขทางซ้าย: 115 unit test ของโมดูลผมผ่านทั้งหมด รวมเทสต์หน้าเว็บ 20 ข้อและเทสต์สิทธิ์ 13 ข้อ 13 เทสต์ตรวจ constraint กับ PostgreSQL จริง และรอบเต็มของทั้งโปรเจคมี 369 เทสต์ผ่านหมด ข้าม 36 ข้อที่ต้องเปิดฐานข้อมูลเอง ซึ่งเมื่อเปิดแล้วรันครบ 379 ข้อ ผ่านทั้งหมด กราฟขวาแสดงเทสต์ที่ผ่านในรอบปกติแยกตามโมดูล ของปอนด์มีเทสต์ที่ต้องต่อฐานข้อมูลอีก 23 ข้อ ซึ่งรันแล้วผ่านเมื่อเปิดสวิตช์ ตรวจตัวเลขทั้งหมดกับ doc/test-report ก่อนนำเสนออีกครั้ง</a:t>
             </a:r>
           </a:p>
         </p:txBody>
@@ -1244,7 +1244,7 @@
           <a:lstStyle/>
           <a:p>
             <a:r>
-              <a:t>ปิดท้ายด้วยข้อจำกัดที่ผมรู้ตรงๆ ครับ ยังไม่มีเทสต์จ่ายซ้ำพร้อมกันจริง ส่วนสิทธิ์ @PreAuthorize ตอนนี้มีเทสต์อัตโนมัติแล้ว 13 ข้อ ที่เปิด Spring Security และ render หน้าเว็บจริง เทสต์ที่ต่อฐานข้อมูลเป็นแบบเปิดเองยังไม่รันใน CI หน้าเว็บชำระเงินกับกล่องแจ้งเตือนทำเสร็จแล้ว ผมเจอบั๊ก dropdown ว่างตอนเปิดหน้าจริง จึงเพิ่มเทสต์ render กันไว้ แต่ฟอร์มยังต้องพิมพ์เลขที่รายการเอง สิ่งที่ทำต่อคือเพิ่ม Postgres ใน CI และเพิ่มปุ่มชำระเงินจากหน้าประวัติรอบใช้งานของปอนด์ เพื่อให้ flow ตั้งแต่จองจนถึงจ่ายเงินครบในหน้าเว็บ ขอบคุณครับ</a:t>
+              <a:t>ปิดท้ายด้วยข้อจำกัดที่ผมรู้ตรงๆ ครับ ยังไม่มีเทสต์จ่ายซ้ำพร้อมกันจริง ส่วนสิทธิ์ @PreAuthorize ตอนนี้มีเทสต์อัตโนมัติแล้ว 13 ข้อ ที่เปิด Spring Security และ render หน้าเว็บจริง เทสต์ที่ต่อฐานข้อมูลเป็นแบบเปิดเองยังไม่รันใน CI หน้าเว็บชำระเงินกับกล่องแจ้งเตือนทำเสร็จแล้ว และเพื่อนทำปุ่มชำระเงินจากหน้าออเดอร์กับหน้าประวัติรอบใช้งานต่อให้ ผมเจอบั๊ก dropdown ว่างตอนเปิดหน้าจริง จึงเพิ่มเทสต์ render กันไว้ ข้อจำกัดที่ต้องบอกคือสัญญา Payable ไม่มีสถานะ ออเดอร์ที่ยกเลิกแล้วยังชำระผ่าน API ได้ สิ่งที่ทำต่อคือเพิ่ม Postgres ใน CI และเพิ่มข้อมูลสถานะใน Payable ให้ Facade ตรวจได้ว่ารายการยกเลิกแล้วหรือไม่ ขอบคุณครับ</a:t>
             </a:r>
           </a:p>
         </p:txBody>
@@ -5120,7 +5120,7 @@
                 <a:ea typeface="Tahoma"/>
                 <a:cs typeface="Tahoma"/>
               </a:rPr>
-              <a:t>102</a:t>
+              <a:t>115</a:t>
             </a:r>
           </a:p>
         </p:txBody>
@@ -8819,7 +8819,7 @@
                 <a:ea typeface="Tahoma"/>
                 <a:cs typeface="Tahoma"/>
               </a:rPr>
-              <a:t>102</a:t>
+              <a:t>115</a:t>
             </a:r>
           </a:p>
         </p:txBody>
@@ -9077,7 +9077,7 @@
                 <a:ea typeface="Tahoma"/>
                 <a:cs typeface="Tahoma"/>
               </a:rPr>
-              <a:t>346</a:t>
+              <a:t>369</a:t>
             </a:r>
           </a:p>
         </p:txBody>
@@ -10321,7 +10321,7 @@
                 <a:ea typeface="Tahoma"/>
                 <a:cs typeface="Tahoma"/>
               </a:rPr>
-              <a:t>•  ฟอร์มชำระเงินต้องพิมพ์เลขที่รายการเอง</a:t>
+              <a:t>•  Payable ไม่มีสถานะ ออเดอร์ที่ยกเลิกแล้วยังชำระผ่าน API ได้</a:t>
             </a:r>
           </a:p>
         </p:txBody>
@@ -10444,7 +10444,7 @@
                 <a:ea typeface="Tahoma"/>
                 <a:cs typeface="Tahoma"/>
               </a:rPr>
-              <a:t>•  ปุ่มชำระเงินจากหน้าประวัติรอบใช้งาน / ออเดอร์</a:t>
+              <a:t>•  เพิ่มสถานะใน Payable กันชำระรายการที่ยกเลิกแล้ว</a:t>
             </a:r>
           </a:p>
           <a:p>

</xml_diff>

<commit_message>
docs: update test totals to 380/390 and publish final report v10 with self-service evidence
</commit_message>
<xml_diff>
--- a/doc/slide/shogun-payment-notification.pptx
+++ b/doc/slide/shogun-payment-notification.pptx
@@ -193,16 +193,16 @@
                 <c:formatCode>General</c:formatCode>
                 <c:ptCount val="4"/>
                 <c:pt idx="0">
-                  <c:v>115</c:v>
+                  <c:v>118</c:v>
                 </c:pt>
                 <c:pt idx="1">
-                  <c:v>29</c:v>
+                  <c:v>32</c:v>
                 </c:pt>
                 <c:pt idx="2">
-                  <c:v>78</c:v>
+                  <c:v>79</c:v>
                 </c:pt>
                 <c:pt idx="3">
-                  <c:v>111</c:v>
+                  <c:v>114</c:v>
                 </c:pt>
               </c:numCache>
             </c:numRef>
@@ -1104,7 +1104,7 @@
           <a:lstStyle/>
           <a:p>
             <a:r>
-              <a:t>เรื่องการทดสอบ ตัวเลขทางซ้าย: 115 unit test ของโมดูลผมผ่านทั้งหมด รวมเทสต์หน้าเว็บ 20 ข้อและเทสต์สิทธิ์ 13 ข้อ 13 เทสต์ตรวจ constraint กับ PostgreSQL จริง และรอบเต็มของทั้งโปรเจคมี 369 เทสต์ผ่านหมด ข้าม 36 ข้อที่ต้องเปิดฐานข้อมูลเอง ซึ่งเมื่อเปิดแล้วรันครบ 379 ข้อ ผ่านทั้งหมด กราฟขวาแสดงเทสต์ที่ผ่านในรอบปกติแยกตามโมดูล ของปอนด์มีเทสต์ที่ต้องต่อฐานข้อมูลอีก 23 ข้อ ซึ่งรันแล้วผ่านเมื่อเปิดสวิตช์ ตรวจตัวเลขทั้งหมดกับ doc/test-report ก่อนนำเสนออีกครั้ง</a:t>
+              <a:t>เรื่องการทดสอบ ตัวเลขทางซ้าย: 118 unit test ของโมดูลผมผ่านทั้งหมด รวมเทสต์หน้าเว็บ 20 ข้อและเทสต์สิทธิ์ 13 ข้อ 13 เทสต์ตรวจ constraint กับ PostgreSQL จริง และรอบเต็มของทั้งโปรเจคมี 380 เทสต์ผ่านหมด ข้าม 37 ข้อที่ต้องเปิดฐานข้อมูลเอง ซึ่งเมื่อเปิดแล้วรันครบ 390 ข้อ ผ่านทั้งหมด กราฟขวาแสดงเทสต์ที่ผ่านในรอบปกติแยกตามโมดูล ของปอนด์มีเทสต์ที่ต้องต่อฐานข้อมูลอีก 23 ข้อ ซึ่งรันแล้วผ่านเมื่อเปิดสวิตช์ ตรวจตัวเลขทั้งหมดกับ doc/test-report ก่อนนำเสนออีกครั้ง</a:t>
             </a:r>
           </a:p>
         </p:txBody>
@@ -5120,7 +5120,7 @@
                 <a:ea typeface="Tahoma"/>
                 <a:cs typeface="Tahoma"/>
               </a:rPr>
-              <a:t>115</a:t>
+              <a:t>118</a:t>
             </a:r>
           </a:p>
         </p:txBody>
@@ -8819,7 +8819,7 @@
                 <a:ea typeface="Tahoma"/>
                 <a:cs typeface="Tahoma"/>
               </a:rPr>
-              <a:t>115</a:t>
+              <a:t>118</a:t>
             </a:r>
           </a:p>
         </p:txBody>
@@ -9077,7 +9077,7 @@
                 <a:ea typeface="Tahoma"/>
                 <a:cs typeface="Tahoma"/>
               </a:rPr>
-              <a:t>369</a:t>
+              <a:t>380</a:t>
             </a:r>
           </a:p>
         </p:txBody>
@@ -9119,7 +9119,7 @@
                 <a:cs typeface="Tahoma"/>
               </a:rPr>
               <a:t>เทสต์ทั้งโปรเจค ผ่านหมด
-(ข้าม 36 ที่ต้องเปิด DB)</a:t>
+(ข้าม 37 ที่ต้องเปิด DB)</a:t>
             </a:r>
           </a:p>
         </p:txBody>

</xml_diff>